<commit_message>
Edit the deck's prose to read like the presenters wrote it
Slide body text, captions and speaker notes lose connector dashes,
not-X-but-Y contrasts and restating closers, and use US spelling. Claim
titles, the three Moment scripts and the Q&A answers keep the spec's
wording. No numbers or bindings changed; exports rebuilt.

Co-Authored-By: Claude Opus 5.5 <noreply@anthropic.com>
Claude-Session: https://claude.ai/code/session_01NeWuNVngVbL3fN4ztcpZQa
</commit_message>
<xml_diff>
--- a/cs667-deck/export/CS667_Technical_Presentation.pptx
+++ b/cs667-deck/export/CS667_Technical_Presentation.pptx
@@ -608,7 +608,7 @@
           <a:p/>
           <a:p>
             <a:r>
-              <a:t>History is built from strictly earlier inspections: the shift comes before the statistic, and the notebook proves it — every restaurant's first row starts with zero history. ZIP is excluded on purpose; borough and coordinates carry location.</a:t>
+              <a:t>History is built from strictly earlier inspections: the shift comes before the statistic, and the notebook proves it: every restaurant's first row starts with zero history. ZIP is excluded on purpose; borough and coordinates carry location.</a:t>
             </a:r>
           </a:p>
           <a:p/>
@@ -626,7 +626,7 @@
           <a:p/>
           <a:p>
             <a:r>
-              <a:t>Also from slide 9: "isn't inspection type leakage?" — type is known before the visit, so it is a fair feature.</a:t>
+              <a:t>Also from slide 9: "isn't inspection type leakage?" Type is known before the visit, so it is a fair feature.</a:t>
             </a:r>
           </a:p>
         </p:txBody>
@@ -702,7 +702,7 @@
           <a:p/>
           <a:p>
             <a:r>
-              <a:t>Identical treatment for train and test. PCA on the numeric features spreads variance across components — PC1 21.8%, PC2 16.6%, 8 of 11 components for 90% — so the features are not copies of each other, and the originals stay because they can be explained in words.</a:t>
+              <a:t>Identical treatment for train and test. PCA on the numeric features spreads the variance across components (PC1 21.8%, PC2 16.6%, 8 of 11 components for 90%), so the features are not copies of each other, and the originals stay because they can be explained in words.</a:t>
             </a:r>
           </a:p>
           <a:p/>
@@ -784,7 +784,7 @@
           <a:p/>
           <a:p>
             <a:r>
-              <a:t>Read the gaps, not the bars. Logistic regression: 0.644 train, 0.644 test. Random forest: 1.000 train, 0.641 test — it memorized the training years. Gradient boosting sits between: 0.870 / 0.636.</a:t>
+              <a:t>Read the gaps, not the bars. Logistic regression: 0.644 train, 0.644 test. Random forest: 1.000 train, 0.641 test. It memorized the training years. Gradient boosting sits between: 0.870 / 0.636.</a:t>
             </a:r>
           </a:p>
           <a:p/>
@@ -884,7 +884,7 @@
           <a:p/>
           <a:p>
             <a:r>
-              <a:t>Never cut the drag. At 0.45: recall 82.2%, precision 37.6% — the highest threshold that still catches at least 80% of B or C. The slider stops only at thresholds the model was evaluated at; it never interpolates. Arrow keys move it; Esc or click outside returns the keys to the slides.</a:t>
+              <a:t>Never cut the drag. At 0.45: recall 82.2%, precision 37.6%. It is the highest threshold that still catches at least 80% of B or C. The slider stops only at thresholds the model was evaluated at; it never interpolates. Arrow keys move it; Esc or click outside returns the keys to the slides.</a:t>
             </a:r>
           </a:p>
           <a:p/>
@@ -966,7 +966,7 @@
           <a:p/>
           <a:p>
             <a:r>
-              <a:t>"The frame was fixed before we started: a deadline, a public raw dataset, set deliverables. That is a waterfall plan, the top row. Underneath it we ran two one-week sprints. On October 21, building the visit-type maps, we found that first visits never get a B or C. We rebuilt the modeling population that same day. A pure waterfall plan would have shipped a model trained on the wrong target. The deadline never moved. The plan underneath it did, once, on evidence."</a:t>
+              <a:t>"Before we started, the deadline, the data source and the deliverables were already fixed. That's a waterfall plan, the top row. Underneath it we ran two one-week sprints. On October 21, building the visit-type maps, we found that first visits never get a B or C. We rebuilt the modeling population that same day. A pure waterfall plan would have shipped a model trained on the wrong target. The deadline never moved. The plan underneath it did, once, on evidence."</a:t>
             </a:r>
           </a:p>
         </p:txBody>
@@ -1042,7 +1042,7 @@
           <a:p/>
           <a:p>
             <a:r>
-              <a:t>Close the opening question: yes, a bad grade is partly visible before the inspector walks in — 0.644 ranking quality, 82.2% of bad inspections caught at 0.45, and the worst ZIP at 33.3% against 12.9% citywide.</a:t>
+              <a:t>Close the opening question: yes, a bad grade is partly visible before the inspector walks in. We get 0.644 ranking quality, 82.2% of bad inspections caught at 0.45, and the worst ZIP at 33.3% against 12.9% citywide.</a:t>
             </a:r>
           </a:p>
           <a:p/>
@@ -1334,7 +1334,7 @@
           <a:lstStyle/>
           <a:p>
             <a:r>
-              <a:t>Backup, Q&amp;A only. Use for "why trust the red areas?" — see slide 8's notes for the full answer.</a:t>
+              <a:t>Backup, Q&amp;A only. Use for "why trust the red areas?" The full answer is in slide 8's notes.</a:t>
             </a:r>
           </a:p>
         </p:txBody>
@@ -1416,7 +1416,7 @@
           <a:p/>
           <a:p>
             <a:r>
-              <a:t>Point at the red box before any result appears: nothing measured during the inspection itself is ever a predictor. That is the leakage rule, and every later slide obeys it.</a:t>
+              <a:t>Point at the red box before any result appears: nothing measured during the inspection itself is ever a predictor. That is the leakage rule, and every later slide follows it.</a:t>
             </a:r>
           </a:p>
         </p:txBody>
@@ -1826,7 +1826,7 @@
           <a:p/>
           <a:p>
             <a:r>
-              <a:t>Score and critical violations correlate at 0.86 — but the score is made of violation points, so that is arithmetic. Latitude and longitude at −1.00 is the city's diagonal shape. Naming both traps here is what makes the deck Q&amp;A-proof.</a:t>
+              <a:t>Score and critical violations correlate at 0.86, but the score is made of violation points, so that is arithmetic. Latitude and longitude at −1.00 is the city's diagonal shape. Naming both traps here is what makes the deck Q&amp;A-proof.</a:t>
             </a:r>
           </a:p>
           <a:p/>

</xml_diff>

<commit_message>
Fill the three figures the notebook printed but never saved
source/deck_exports.json (team-supplied, October 21 run) carries the 8,456
same-day pairs, the 41.8% / 37.1% scored-14+ shares and the 99.6% ZIP
boundary match. The exporter accepts it only if every share equals its
own counts and the 14+ counts fit the per-ZIP map data. No value is
awaiting export now; the 'Scored 14+' maps show their headline shares.

Co-Authored-By: Claude Opus 5.5 <noreply@anthropic.com>
Claude-Session: https://claude.ai/code/session_01NeWuNVngVbL3fN4ztcpZQa
</commit_message>
<xml_diff>
--- a/cs667-deck/export/CS667_Technical_Presentation.pptx
+++ b/cs667-deck/export/CS667_Technical_Presentation.pptx
@@ -1498,7 +1498,7 @@
           <a:p/>
           <a:p>
             <a:r>
-              <a:t>The key is restaurant + date + inspection type. Date alone would wrongly merge awaiting export same-day pairs into fake inspections.</a:t>
+              <a:t>The key is restaurant + date + inspection type. Date alone would wrongly merge 8,456 same-day pairs into fake inspections.</a:t>
             </a:r>
           </a:p>
         </p:txBody>
@@ -1920,7 +1920,7 @@
           <a:p/>
           <a:p>
             <a:r>
-              <a:t>Q&amp;A armor: "ZIP/NTA rates rest on wildly different counts — why trust the red areas?" — Only regions with at least 30 graded inspections earn a color; the rest are greyed "not enough inspections to judge"; counts ride in every tooltip and are printed for the headline ZIP (342 graded); the boundary match is awaiting export; and the stated limit: a high-rate ZIP describes inspected activity there, not any single restaurant in it.</a:t>
+              <a:t>Q&amp;A armor: "ZIP/NTA rates rest on wildly different counts — why trust the red areas?" — Only regions with at least 30 graded inspections earn a color; the rest are greyed "not enough inspections to judge"; counts ride in every tooltip and are printed for the headline ZIP (342 graded); the boundary match is 99.6%; and the stated limit: a high-rate ZIP describes inspected activity there, not any single restaurant in it.</a:t>
             </a:r>
           </a:p>
           <a:p/>
@@ -2014,7 +2014,7 @@
           <a:p/>
           <a:p>
             <a:r>
-              <a:t>Toggle "Scored 14+" if asked whether first visits really score better: the share of scored inspections at 14+ points is awaiting export on first visits vs awaiting export on re-inspections. First visits do score badly; they just never get the letter.</a:t>
+              <a:t>Toggle "Scored 14+" if asked whether first visits really score better: the share of scored inspections at 14+ points is 41.8% on first visits vs 37.1% on re-inspections. First visits do score badly; they just never get the letter.</a:t>
             </a:r>
           </a:p>
           <a:p/>

</xml_diff>